<commit_message>
docs: add service demo presentation and video
</commit_message>
<xml_diff>
--- a/.codex-output/2609_업무 지침 네비게이터_발표자료.pptx
+++ b/.codex-output/2609_업무 지침 네비게이터_발표자료.pptx
@@ -10760,10 +10760,11 @@
       </p:sp>
       <p:pic>
         <p:nvPicPr>
-          <p:cNvPr id="5" name="그림 4">
+          <p:cNvPr id="11" name="그림 10">
+            <a:hlinkClick r:id="rId5" action="ppaction://hlinkfile"/>
             <a:extLst>
               <a:ext uri="{FF2B5EF4-FFF2-40B4-BE49-F238E27FC236}">
-                <a16:creationId xmlns:a16="http://schemas.microsoft.com/office/drawing/2014/main" id="{049760FB-8D8D-449E-8EE8-5BBAD3465991}"/>
+                <a16:creationId xmlns:a16="http://schemas.microsoft.com/office/drawing/2014/main" id="{1D50F15C-C904-4B41-B2EB-C4E409B40614}"/>
               </a:ext>
             </a:extLst>
           </p:cNvPr>
@@ -10773,15 +10774,15 @@
           <p:nvPr/>
         </p:nvPicPr>
         <p:blipFill>
-          <a:blip r:embed="rId5"/>
+          <a:blip r:embed="rId6"/>
           <a:stretch>
             <a:fillRect/>
           </a:stretch>
         </p:blipFill>
         <p:spPr>
           <a:xfrm>
-            <a:off x="338291" y="1244475"/>
-            <a:ext cx="3497241" cy="2306915"/>
+            <a:off x="388531" y="1258200"/>
+            <a:ext cx="3469595" cy="2233529"/>
           </a:xfrm>
           <a:prstGeom prst="rect">
             <a:avLst/>

</xml_diff>